<commit_message>
Approfondisci teoria: embedding/decoding, ruolo dei σ, perturbazioni (Weyl), scelta parametri
Risponde ai rilievi della revisione: il report, THEORY.md e le slide ora
discutono in dettaglio l'embedding e la decodifica cieca, il ruolo dei
valori singolari nell'embedding, l'effetto delle perturbazioni sulla
ricostruzione (teorema di Weyl, margine QIM Δ/4, bilancio dell'errore)
e le motivazioni teoriche dei parametri (Δ, B, k, R) con PSNR previsto
vs misurato.

Correzioni: '+~10 dB' → +3.0 dB (valore calcolato dai dati), riferimento
'G. Eckart' → 'C. Eckart', fattore di compressione 0.32 → 0.31, aggiunti
riferimenti Weyl e Chen–Wornell (QIM). Fix compatibilità OpenCV 5 in
dataset.default_secret (canvas uint8). Report e presentazione rigenerati.

Co-Authored-By: Claude Fable 5 <noreply@anthropic.com>
Claude-Session: https://claude.ai/code/session_01HZaPXQkHB1yDowMc3NgwtQ
</commit_message>
<xml_diff>
--- a/docs/presentazione.pptx
+++ b/docs/presentazione.pptx
@@ -21,6 +21,10 @@
     <p:sldId id="269" r:id="rId20"/>
     <p:sldId id="270" r:id="rId21"/>
     <p:sldId id="271" r:id="rId22"/>
+    <p:sldId id="272" r:id="rId23"/>
+    <p:sldId id="273" r:id="rId24"/>
+    <p:sldId id="274" r:id="rId25"/>
+    <p:sldId id="275" r:id="rId26"/>
   </p:sldIdLst>
   <p:sldSz cx="12191695" cy="6858000" type="screen4x3"/>
   <p:notesSz cx="6858000" cy="9144000"/>
@@ -3323,45 +3327,21 @@
               </a:defRPr>
             </a:pPr>
             <a:r>
-              <a:t>Risultato chiave — protezione oggetti via YOLO</a:t>
-            </a:r>
-          </a:p>
-        </p:txBody>
-      </p:sp>
-      <p:pic>
-        <p:nvPicPr>
-          <p:cNvPr id="4" name="Picture 3" descr="fig_object_protection.png"/>
-          <p:cNvPicPr>
-            <a:picLocks noChangeAspect="1"/>
-          </p:cNvPicPr>
-          <p:nvPr/>
-        </p:nvPicPr>
-        <p:blipFill>
-          <a:blip r:embed="rId2"/>
-          <a:stretch>
-            <a:fillRect/>
-          </a:stretch>
-        </p:blipFill>
-        <p:spPr>
-          <a:xfrm>
-            <a:off x="457200" y="1325880"/>
-            <a:ext cx="7863840" cy="2758495"/>
-          </a:xfrm>
-          <a:prstGeom prst="rect">
-            <a:avLst/>
-          </a:prstGeom>
-        </p:spPr>
-      </p:pic>
-      <p:sp>
-        <p:nvSpPr>
-          <p:cNvPr id="5" name="TextBox 4"/>
+              <a:t>Effetto delle perturbazioni: teorema di Weyl</a:t>
+            </a:r>
+          </a:p>
+        </p:txBody>
+      </p:sp>
+      <p:sp>
+        <p:nvSpPr>
+          <p:cNvPr id="4" name="TextBox 3"/>
           <p:cNvSpPr txBox="1"/>
           <p:nvPr/>
         </p:nvSpPr>
         <p:spPr>
           <a:xfrm>
-            <a:off x="457200" y="4130095"/>
-            <a:ext cx="7863840" cy="548640"/>
+            <a:off x="640080" y="1143000"/>
+            <a:ext cx="10972800" cy="457200"/>
           </a:xfrm>
           <a:prstGeom prst="rect">
             <a:avLst/>
@@ -3374,29 +3354,29 @@
           </a:bodyPr>
           <a:lstStyle/>
           <a:p>
-            <a:pPr algn="ctr">
-              <a:defRPr sz="1100" i="1">
+            <a:pPr>
+              <a:defRPr sz="1500" i="1">
                 <a:solidFill>
                   <a:srgbClr val="555F6B"/>
                 </a:solidFill>
               </a:defRPr>
             </a:pPr>
             <a:r>
-              <a:t>PSNR oggetti: 47.40 → 50.39 dB con la guida YOLO.</a:t>
-            </a:r>
-          </a:p>
-        </p:txBody>
-      </p:sp>
-      <p:sp>
-        <p:nvSpPr>
-          <p:cNvPr id="6" name="TextBox 5"/>
+              <a:t>I risultati sperimentali sono previsti dalla teoria, non solo osservati</a:t>
+            </a:r>
+          </a:p>
+        </p:txBody>
+      </p:sp>
+      <p:sp>
+        <p:nvSpPr>
+          <p:cNvPr id="5" name="TextBox 4"/>
           <p:cNvSpPr txBox="1"/>
           <p:nvPr/>
         </p:nvSpPr>
         <p:spPr>
           <a:xfrm>
-            <a:off x="8412480" y="1463040"/>
-            <a:ext cx="3566160" cy="4754880"/>
+            <a:off x="640080" y="1783080"/>
+            <a:ext cx="10972800" cy="4754880"/>
           </a:xfrm>
           <a:prstGeom prst="rect">
             <a:avLst/>
@@ -3413,14 +3393,14 @@
               <a:spcAft>
                 <a:spcPts val="800"/>
               </a:spcAft>
-              <a:defRPr sz="1500">
+              <a:defRPr sz="2000">
                 <a:solidFill>
                   <a:srgbClr val="1F3555"/>
                 </a:solidFill>
               </a:defRPr>
             </a:pPr>
             <a:r>
-              <a:t>• I bit vanno nello sfondo</a:t>
+              <a:t>• Attacco = perturbazione E del blocco:  |σᵢ(A'+E) − σᵢ(A')| ≤ ‖E‖₂  ∀i.</a:t>
             </a:r>
           </a:p>
           <a:p>
@@ -3428,14 +3408,14 @@
               <a:spcAft>
                 <a:spcPts val="800"/>
               </a:spcAft>
-              <a:defRPr sz="1500">
+              <a:defRPr sz="2000">
                 <a:solidFill>
                   <a:srgbClr val="1F3555"/>
                 </a:solidFill>
               </a:defRPr>
             </a:pPr>
             <a:r>
-              <a:t>• Oggetti quasi intatti</a:t>
+              <a:t>• Condizione di decodifica corretta: ‖E‖₂ &lt; Δ/4 (margine QIM).</a:t>
             </a:r>
           </a:p>
           <a:p>
@@ -3443,14 +3423,59 @@
               <a:spcAft>
                 <a:spcPts val="800"/>
               </a:spcAft>
-              <a:defRPr sz="1500">
+              <a:defRPr sz="2000">
                 <a:solidFill>
                   <a:srgbClr val="1F3555"/>
                 </a:solidFill>
               </a:defRPr>
             </a:pPr>
             <a:r>
-              <a:t>• +2.99 dB sugli oggetti</a:t>
+              <a:t>• Rumore gaussiano σ_n: ‖E‖₂ ≈ 2σ_n√B. Con σ_n = 5:</a:t>
+            </a:r>
+          </a:p>
+          <a:p>
+            <a:pPr lvl="1">
+              <a:spcAft>
+                <a:spcPts val="800"/>
+              </a:spcAft>
+              <a:defRPr sz="1700">
+                <a:solidFill>
+                  <a:srgbClr val="555F6B"/>
+                </a:solidFill>
+              </a:defRPr>
+            </a:pPr>
+            <a:r>
+              <a:t>– HC: margine Δ/4 = 6 contro ‖E‖₂ ≈ 28 ⇒ fragile (BER misurato 0.37)</a:t>
+            </a:r>
+          </a:p>
+          <a:p>
+            <a:pPr lvl="1">
+              <a:spcAft>
+                <a:spcPts val="800"/>
+              </a:spcAft>
+              <a:defRPr sz="1700">
+                <a:solidFill>
+                  <a:srgbClr val="555F6B"/>
+                </a:solidFill>
+              </a:defRPr>
+            </a:pPr>
+            <a:r>
+              <a:t>– RB: margine Δ/4 = 32 contro ‖E‖₂ ≈ 40 ⇒ errori sporadici, corretti dal voto (BER 0.003)</a:t>
+            </a:r>
+          </a:p>
+          <a:p>
+            <a:pPr>
+              <a:spcAft>
+                <a:spcPts val="800"/>
+              </a:spcAft>
+              <a:defRPr sz="2000">
+                <a:solidFill>
+                  <a:srgbClr val="1F3555"/>
+                </a:solidFill>
+              </a:defRPr>
+            </a:pPr>
+            <a:r>
+              <a:t>• Ricostruzione: errore = troncamento (Eckart–Young, tetto in pulito) + quantizzazione (trascurabile) + errori di bit (U/V graduali, σ e header critici ⇒ header nei primi siti + ripetizione).</a:t>
             </a:r>
           </a:p>
         </p:txBody>
@@ -3546,45 +3571,21 @@
               </a:defRPr>
             </a:pPr>
             <a:r>
-              <a:t>Risultato qualitativo</a:t>
-            </a:r>
-          </a:p>
-        </p:txBody>
-      </p:sp>
-      <p:pic>
-        <p:nvPicPr>
-          <p:cNvPr id="4" name="Picture 3" descr="fig_qualitative.png"/>
-          <p:cNvPicPr>
-            <a:picLocks noChangeAspect="1"/>
-          </p:cNvPicPr>
-          <p:nvPr/>
-        </p:nvPicPr>
-        <p:blipFill>
-          <a:blip r:embed="rId2"/>
-          <a:stretch>
-            <a:fillRect/>
-          </a:stretch>
-        </p:blipFill>
-        <p:spPr>
-          <a:xfrm>
-            <a:off x="2186968" y="1325880"/>
-            <a:ext cx="7817758" cy="4846320"/>
-          </a:xfrm>
-          <a:prstGeom prst="rect">
-            <a:avLst/>
-          </a:prstGeom>
-        </p:spPr>
-      </p:pic>
-      <p:sp>
-        <p:nvSpPr>
-          <p:cNvPr id="5" name="TextBox 4"/>
+              <a:t>Scelta dei parametri: teoria vs misura</a:t>
+            </a:r>
+          </a:p>
+        </p:txBody>
+      </p:sp>
+      <p:sp>
+        <p:nvSpPr>
+          <p:cNvPr id="4" name="TextBox 3"/>
           <p:cNvSpPr txBox="1"/>
           <p:nvPr/>
         </p:nvSpPr>
         <p:spPr>
           <a:xfrm>
-            <a:off x="2186968" y="6217920"/>
-            <a:ext cx="7817758" cy="548640"/>
+            <a:off x="640080" y="1371600"/>
+            <a:ext cx="10972800" cy="4754880"/>
           </a:xfrm>
           <a:prstGeom prst="rect">
             <a:avLst/>
@@ -3597,15 +3598,93 @@
           </a:bodyPr>
           <a:lstStyle/>
           <a:p>
-            <a:pPr algn="ctr">
-              <a:defRPr sz="1100" i="1">
+            <a:pPr>
+              <a:spcAft>
+                <a:spcPts val="800"/>
+              </a:spcAft>
+              <a:defRPr sz="2000">
+                <a:solidFill>
+                  <a:srgbClr val="1F3555"/>
+                </a:solidFill>
+              </a:defRPr>
+            </a:pPr>
+            <a:r>
+              <a:t>• Δ — distorsione prevista: E[δ²] = 7Δ²/48 (fase uniforme) ⇒ PSNR atteso = 10·log₁₀(255²·B²/(α·7Δ²/48)):</a:t>
+            </a:r>
+          </a:p>
+          <a:p>
+            <a:pPr lvl="1">
+              <a:spcAft>
+                <a:spcPts val="800"/>
+              </a:spcAft>
+              <a:defRPr sz="1700">
                 <a:solidFill>
                   <a:srgbClr val="555F6B"/>
                 </a:solidFill>
               </a:defRPr>
             </a:pPr>
             <a:r>
-              <a:t>La mappa |cover−stego| evita le regioni degli oggetti rilevati da YOLO.</a:t>
+              <a:t>– HC: atteso 47.6 dB, misurato 47.4 dB · RB: atteso 39.0 dB, misurato 39.0 dB (scarto &lt; 0.3 dB)</a:t>
+            </a:r>
+          </a:p>
+          <a:p>
+            <a:pPr>
+              <a:spcAft>
+                <a:spcPts val="800"/>
+              </a:spcAft>
+              <a:defRPr sz="2000">
+                <a:solidFill>
+                  <a:srgbClr val="1F3555"/>
+                </a:solidFill>
+              </a:defRPr>
+            </a:pPr>
+            <a:r>
+              <a:t>• Δ — robustezza (Weyl): Δ &gt; 8σ_n√B ⇒ RB tollera σ_n ≈ 4, HC solo ≈ 0.75.</a:t>
+            </a:r>
+          </a:p>
+          <a:p>
+            <a:pPr>
+              <a:spcAft>
+                <a:spcPts val="800"/>
+              </a:spcAft>
+              <a:defRPr sz="2000">
+                <a:solidFill>
+                  <a:srgbClr val="1F3555"/>
+                </a:solidFill>
+              </a:defRPr>
+            </a:pPr>
+            <a:r>
+              <a:t>• B — capacità 3(N/B)²: 12288 siti (B=8) vs 3072 (B=16); ma σ₁ ≈ cB cresce come B mentre ‖E‖₂ solo come √B ⇒ blocchi grandi più robusti.</a:t>
+            </a:r>
+          </a:p>
+          <a:p>
+            <a:pPr>
+              <a:spcAft>
+                <a:spcPts val="800"/>
+              </a:spcAft>
+              <a:defRPr sz="2000">
+                <a:solidFill>
+                  <a:srgbClr val="1F3555"/>
+                </a:solidFill>
+              </a:defRPr>
+            </a:pPr>
+            <a:r>
+              <a:t>• k — criterio dell'energia: k=10 è il minimo con E(k) ≥ 99 % (E(10)=99.1 %); vincolo di capacità: 10472 bit su 12288 (k=12 non entrerebbe). In RB k=3 è il massimo compatibile con R=3.</a:t>
+            </a:r>
+          </a:p>
+          <a:p>
+            <a:pPr>
+              <a:spcAft>
+                <a:spcPts val="800"/>
+              </a:spcAft>
+              <a:defRPr sz="2000">
+                <a:solidFill>
+                  <a:srgbClr val="1F3555"/>
+                </a:solidFill>
+              </a:defRPr>
+            </a:pPr>
+            <a:r>
+              <a:t>• R — dispari (maggioranza senza pareggi): errore logico ≈ 3p² con R=3 (p=5 % → 0.7 %), al costo di 1/3 della capacità.</a:t>
             </a:r>
           </a:p>
         </p:txBody>
@@ -3701,205 +3780,120 @@
               </a:defRPr>
             </a:pPr>
             <a:r>
-              <a:t>Preservazione semantica (downstream YOLO)</a:t>
-            </a:r>
-          </a:p>
-        </p:txBody>
-      </p:sp>
-      <p:sp>
-        <p:nvSpPr>
-          <p:cNvPr id="4" name="Rectangle 3"/>
-          <p:cNvSpPr/>
-          <p:nvPr/>
-        </p:nvSpPr>
-        <p:spPr>
-          <a:xfrm>
-            <a:off x="548640" y="2011680"/>
-            <a:ext cx="3515258" cy="2377440"/>
-          </a:xfrm>
-          <a:prstGeom prst="rect">
-            <a:avLst/>
-          </a:prstGeom>
-          <a:solidFill>
-            <a:srgbClr val="F2F4F6"/>
-          </a:solidFill>
-          <a:ln w="25400">
-            <a:solidFill>
-              <a:srgbClr val="2E6DA4"/>
-            </a:solidFill>
-          </a:ln>
-        </p:spPr>
-        <p:style>
-          <a:lnRef idx="1">
-            <a:schemeClr val="accent1"/>
-          </a:lnRef>
-          <a:fillRef idx="3">
-            <a:schemeClr val="accent1"/>
-          </a:fillRef>
-          <a:effectRef idx="2">
-            <a:schemeClr val="accent1"/>
-          </a:effectRef>
-          <a:fontRef idx="minor">
-            <a:schemeClr val="lt1"/>
-          </a:fontRef>
-        </p:style>
-        <p:txBody>
-          <a:bodyPr rtlCol="0" anchor="ctr" wrap="square"/>
-          <a:lstStyle/>
-          <a:p>
-            <a:pPr algn="ctr">
-              <a:defRPr sz="3400" b="1">
-                <a:solidFill>
-                  <a:srgbClr val="2E6DA4"/>
-                </a:solidFill>
-              </a:defRPr>
-            </a:pPr>
-            <a:r>
-              <a:t>0.961</a:t>
-            </a:r>
-          </a:p>
-          <a:p>
-            <a:pPr algn="ctr">
-              <a:defRPr sz="1400">
+              <a:t>Setup sperimentale</a:t>
+            </a:r>
+          </a:p>
+        </p:txBody>
+      </p:sp>
+      <p:sp>
+        <p:nvSpPr>
+          <p:cNvPr id="4" name="TextBox 3"/>
+          <p:cNvSpPr txBox="1"/>
+          <p:nvPr/>
+        </p:nvSpPr>
+        <p:spPr>
+          <a:xfrm>
+            <a:off x="640080" y="1371600"/>
+            <a:ext cx="10972800" cy="4754880"/>
+          </a:xfrm>
+          <a:prstGeom prst="rect">
+            <a:avLst/>
+          </a:prstGeom>
+          <a:noFill/>
+        </p:spPr>
+        <p:txBody>
+          <a:bodyPr wrap="square">
+            <a:spAutoFit/>
+          </a:bodyPr>
+          <a:lstStyle/>
+          <a:p>
+            <a:pPr>
+              <a:spcAft>
+                <a:spcPts val="800"/>
+              </a:spcAft>
+              <a:defRPr sz="2000">
+                <a:solidFill>
+                  <a:srgbClr val="1F3555"/>
+                </a:solidFill>
+              </a:defRPr>
+            </a:pPr>
+            <a:r>
+              <a:t>• Dataset: COCO-128 — 128 immagini reali di COCO, cover 512×512.</a:t>
+            </a:r>
+          </a:p>
+          <a:p>
+            <a:pPr>
+              <a:spcAft>
+                <a:spcPts val="800"/>
+              </a:spcAft>
+              <a:defRPr sz="2000">
+                <a:solidFill>
+                  <a:srgbClr val="1F3555"/>
+                </a:solidFill>
+              </a:defRPr>
+            </a:pPr>
+            <a:r>
+              <a:t>• Due punti operativi:</a:t>
+            </a:r>
+          </a:p>
+          <a:p>
+            <a:pPr lvl="1">
+              <a:spcAft>
+                <a:spcPts val="800"/>
+              </a:spcAft>
+              <a:defRPr sz="1700">
                 <a:solidFill>
                   <a:srgbClr val="555F6B"/>
                 </a:solidFill>
               </a:defRPr>
             </a:pPr>
             <a:r>
-              <a:t>preservation rate</a:t>
-            </a:r>
-          </a:p>
-        </p:txBody>
-      </p:sp>
-      <p:sp>
-        <p:nvSpPr>
-          <p:cNvPr id="5" name="Rectangle 4"/>
-          <p:cNvSpPr/>
-          <p:nvPr/>
-        </p:nvSpPr>
-        <p:spPr>
-          <a:xfrm>
-            <a:off x="4338218" y="2011680"/>
-            <a:ext cx="3515258" cy="2377440"/>
-          </a:xfrm>
-          <a:prstGeom prst="rect">
-            <a:avLst/>
-          </a:prstGeom>
-          <a:solidFill>
-            <a:srgbClr val="F2F4F6"/>
-          </a:solidFill>
-          <a:ln w="25400">
-            <a:solidFill>
-              <a:srgbClr val="2E6DA4"/>
-            </a:solidFill>
-          </a:ln>
-        </p:spPr>
-        <p:style>
-          <a:lnRef idx="1">
-            <a:schemeClr val="accent1"/>
-          </a:lnRef>
-          <a:fillRef idx="3">
-            <a:schemeClr val="accent1"/>
-          </a:fillRef>
-          <a:effectRef idx="2">
-            <a:schemeClr val="accent1"/>
-          </a:effectRef>
-          <a:fontRef idx="minor">
-            <a:schemeClr val="lt1"/>
-          </a:fontRef>
-        </p:style>
-        <p:txBody>
-          <a:bodyPr rtlCol="0" anchor="ctr" wrap="square"/>
-          <a:lstStyle/>
-          <a:p>
-            <a:pPr algn="ctr">
-              <a:defRPr sz="3400" b="1">
-                <a:solidFill>
-                  <a:srgbClr val="2E6DA4"/>
-                </a:solidFill>
-              </a:defRPr>
-            </a:pPr>
-            <a:r>
-              <a:t>0.959</a:t>
-            </a:r>
-          </a:p>
-          <a:p>
-            <a:pPr algn="ctr">
-              <a:defRPr sz="1400">
+              <a:t>– High-Capacity (HC): blocco 8×8, Δ=24.0, R=1, segreto 64², k=10</a:t>
+            </a:r>
+          </a:p>
+          <a:p>
+            <a:pPr lvl="1">
+              <a:spcAft>
+                <a:spcPts val="800"/>
+              </a:spcAft>
+              <a:defRPr sz="1700">
                 <a:solidFill>
                   <a:srgbClr val="555F6B"/>
                 </a:solidFill>
               </a:defRPr>
             </a:pPr>
             <a:r>
-              <a:t>mAP@0.5 stego vs cover</a:t>
-            </a:r>
-          </a:p>
-        </p:txBody>
-      </p:sp>
-      <p:sp>
-        <p:nvSpPr>
-          <p:cNvPr id="6" name="Rectangle 5"/>
-          <p:cNvSpPr/>
-          <p:nvPr/>
-        </p:nvSpPr>
-        <p:spPr>
-          <a:xfrm>
-            <a:off x="8127796" y="2011680"/>
-            <a:ext cx="3515258" cy="2377440"/>
-          </a:xfrm>
-          <a:prstGeom prst="rect">
-            <a:avLst/>
-          </a:prstGeom>
-          <a:solidFill>
-            <a:srgbClr val="F2F4F6"/>
-          </a:solidFill>
-          <a:ln w="25400">
-            <a:solidFill>
-              <a:srgbClr val="2E6DA4"/>
-            </a:solidFill>
-          </a:ln>
-        </p:spPr>
-        <p:style>
-          <a:lnRef idx="1">
-            <a:schemeClr val="accent1"/>
-          </a:lnRef>
-          <a:fillRef idx="3">
-            <a:schemeClr val="accent1"/>
-          </a:fillRef>
-          <a:effectRef idx="2">
-            <a:schemeClr val="accent1"/>
-          </a:effectRef>
-          <a:fontRef idx="minor">
-            <a:schemeClr val="lt1"/>
-          </a:fontRef>
-        </p:style>
-        <p:txBody>
-          <a:bodyPr rtlCol="0" anchor="ctr" wrap="square"/>
-          <a:lstStyle/>
-          <a:p>
-            <a:pPr algn="ctr">
-              <a:defRPr sz="3400" b="1">
-                <a:solidFill>
-                  <a:srgbClr val="2E6DA4"/>
-                </a:solidFill>
-              </a:defRPr>
-            </a:pPr>
-            <a:r>
-              <a:t>0.016</a:t>
-            </a:r>
-          </a:p>
-          <a:p>
-            <a:pPr algn="ctr">
-              <a:defRPr sz="1400">
-                <a:solidFill>
-                  <a:srgbClr val="555F6B"/>
-                </a:solidFill>
-              </a:defRPr>
-            </a:pPr>
-            <a:r>
-              <a:t>|Δ confidenza| medio</a:t>
+              <a:t>– Robust (RB): blocco 16×16, Δ=128.0, R=3, segreto 16², k=3</a:t>
+            </a:r>
+          </a:p>
+          <a:p>
+            <a:pPr>
+              <a:spcAft>
+                <a:spcPts val="800"/>
+              </a:spcAft>
+              <a:defRPr sz="2000">
+                <a:solidFill>
+                  <a:srgbClr val="1F3555"/>
+                </a:solidFill>
+              </a:defRPr>
+            </a:pPr>
+            <a:r>
+              <a:t>• Metriche: PSNR, SSIM, MSE; NC e BER del segreto; mAP@0.5 / preservation rate.</a:t>
+            </a:r>
+          </a:p>
+          <a:p>
+            <a:pPr>
+              <a:spcAft>
+                <a:spcPts val="800"/>
+              </a:spcAft>
+              <a:defRPr sz="2000">
+                <a:solidFill>
+                  <a:srgbClr val="1F3555"/>
+                </a:solidFill>
+              </a:defRPr>
+            </a:pPr>
+            <a:r>
+              <a:t>• Attacchi: JPEG q90/q75/q50, rumore gaussiano, blur, mediano, sale&amp;pepe, rescale.</a:t>
             </a:r>
           </a:p>
         </p:txBody>
@@ -3995,66 +3989,271 @@
               </a:defRPr>
             </a:pPr>
             <a:r>
-              <a:t>Recupero del segreto e compressione</a:t>
-            </a:r>
-          </a:p>
-        </p:txBody>
-      </p:sp>
-      <p:pic>
-        <p:nvPicPr>
-          <p:cNvPr id="4" name="Picture 3" descr="fig_secret_compression.png"/>
-          <p:cNvPicPr>
-            <a:picLocks noChangeAspect="1"/>
-          </p:cNvPicPr>
-          <p:nvPr/>
-        </p:nvPicPr>
-        <p:blipFill>
-          <a:blip r:embed="rId2"/>
-          <a:stretch>
-            <a:fillRect/>
-          </a:stretch>
-        </p:blipFill>
-        <p:spPr>
-          <a:xfrm>
-            <a:off x="700887" y="1325880"/>
-            <a:ext cx="10789920" cy="3784911"/>
-          </a:xfrm>
-          <a:prstGeom prst="rect">
-            <a:avLst/>
-          </a:prstGeom>
-        </p:spPr>
-      </p:pic>
-      <p:sp>
-        <p:nvSpPr>
-          <p:cNvPr id="5" name="TextBox 4"/>
-          <p:cNvSpPr txBox="1"/>
-          <p:nvPr/>
-        </p:nvSpPr>
-        <p:spPr>
-          <a:xfrm>
-            <a:off x="700887" y="5156511"/>
-            <a:ext cx="10789920" cy="548640"/>
-          </a:xfrm>
-          <a:prstGeom prst="rect">
-            <a:avLst/>
-          </a:prstGeom>
-          <a:noFill/>
-        </p:spPr>
-        <p:txBody>
-          <a:bodyPr wrap="square">
-            <a:spAutoFit/>
-          </a:bodyPr>
+              <a:t>Risultati — impercettibilità (HC)</a:t>
+            </a:r>
+          </a:p>
+        </p:txBody>
+      </p:sp>
+      <p:sp>
+        <p:nvSpPr>
+          <p:cNvPr id="4" name="Rectangle 3"/>
+          <p:cNvSpPr/>
+          <p:nvPr/>
+        </p:nvSpPr>
+        <p:spPr>
+          <a:xfrm>
+            <a:off x="548640" y="2011680"/>
+            <a:ext cx="2567863" cy="2377440"/>
+          </a:xfrm>
+          <a:prstGeom prst="rect">
+            <a:avLst/>
+          </a:prstGeom>
+          <a:solidFill>
+            <a:srgbClr val="F2F4F6"/>
+          </a:solidFill>
+          <a:ln w="25400">
+            <a:solidFill>
+              <a:srgbClr val="2E6DA4"/>
+            </a:solidFill>
+          </a:ln>
+        </p:spPr>
+        <p:style>
+          <a:lnRef idx="1">
+            <a:schemeClr val="accent1"/>
+          </a:lnRef>
+          <a:fillRef idx="3">
+            <a:schemeClr val="accent1"/>
+          </a:fillRef>
+          <a:effectRef idx="2">
+            <a:schemeClr val="accent1"/>
+          </a:effectRef>
+          <a:fontRef idx="minor">
+            <a:schemeClr val="lt1"/>
+          </a:fontRef>
+        </p:style>
+        <p:txBody>
+          <a:bodyPr rtlCol="0" anchor="ctr" wrap="square"/>
           <a:lstStyle/>
           <a:p>
             <a:pPr algn="ctr">
-              <a:defRPr sz="1100" i="1">
+              <a:defRPr sz="3400" b="1">
+                <a:solidFill>
+                  <a:srgbClr val="2E6DA4"/>
+                </a:solidFill>
+              </a:defRPr>
+            </a:pPr>
+            <a:r>
+              <a:t>47.39 dB</a:t>
+            </a:r>
+          </a:p>
+          <a:p>
+            <a:pPr algn="ctr">
+              <a:defRPr sz="1400">
                 <a:solidFill>
                   <a:srgbClr val="555F6B"/>
                 </a:solidFill>
               </a:defRPr>
             </a:pPr>
             <a:r>
-              <a:t>Il limite in pulito è dato dalla compressione SVD del segreto, non dall'estrazione.</a:t>
+              <a:t>PSNR cover→stego</a:t>
+            </a:r>
+          </a:p>
+        </p:txBody>
+      </p:sp>
+      <p:sp>
+        <p:nvSpPr>
+          <p:cNvPr id="5" name="Rectangle 4"/>
+          <p:cNvSpPr/>
+          <p:nvPr/>
+        </p:nvSpPr>
+        <p:spPr>
+          <a:xfrm>
+            <a:off x="3390823" y="2011680"/>
+            <a:ext cx="2567863" cy="2377440"/>
+          </a:xfrm>
+          <a:prstGeom prst="rect">
+            <a:avLst/>
+          </a:prstGeom>
+          <a:solidFill>
+            <a:srgbClr val="F2F4F6"/>
+          </a:solidFill>
+          <a:ln w="25400">
+            <a:solidFill>
+              <a:srgbClr val="2E6DA4"/>
+            </a:solidFill>
+          </a:ln>
+        </p:spPr>
+        <p:style>
+          <a:lnRef idx="1">
+            <a:schemeClr val="accent1"/>
+          </a:lnRef>
+          <a:fillRef idx="3">
+            <a:schemeClr val="accent1"/>
+          </a:fillRef>
+          <a:effectRef idx="2">
+            <a:schemeClr val="accent1"/>
+          </a:effectRef>
+          <a:fontRef idx="minor">
+            <a:schemeClr val="lt1"/>
+          </a:fontRef>
+        </p:style>
+        <p:txBody>
+          <a:bodyPr rtlCol="0" anchor="ctr" wrap="square"/>
+          <a:lstStyle/>
+          <a:p>
+            <a:pPr algn="ctr">
+              <a:defRPr sz="3400" b="1">
+                <a:solidFill>
+                  <a:srgbClr val="2E6DA4"/>
+                </a:solidFill>
+              </a:defRPr>
+            </a:pPr>
+            <a:r>
+              <a:t>0.9950</a:t>
+            </a:r>
+          </a:p>
+          <a:p>
+            <a:pPr algn="ctr">
+              <a:defRPr sz="1400">
+                <a:solidFill>
+                  <a:srgbClr val="555F6B"/>
+                </a:solidFill>
+              </a:defRPr>
+            </a:pPr>
+            <a:r>
+              <a:t>SSIM</a:t>
+            </a:r>
+          </a:p>
+        </p:txBody>
+      </p:sp>
+      <p:sp>
+        <p:nvSpPr>
+          <p:cNvPr id="6" name="Rectangle 5"/>
+          <p:cNvSpPr/>
+          <p:nvPr/>
+        </p:nvSpPr>
+        <p:spPr>
+          <a:xfrm>
+            <a:off x="6233007" y="2011680"/>
+            <a:ext cx="2567863" cy="2377440"/>
+          </a:xfrm>
+          <a:prstGeom prst="rect">
+            <a:avLst/>
+          </a:prstGeom>
+          <a:solidFill>
+            <a:srgbClr val="F2F4F6"/>
+          </a:solidFill>
+          <a:ln w="25400">
+            <a:solidFill>
+              <a:srgbClr val="2E6DA4"/>
+            </a:solidFill>
+          </a:ln>
+        </p:spPr>
+        <p:style>
+          <a:lnRef idx="1">
+            <a:schemeClr val="accent1"/>
+          </a:lnRef>
+          <a:fillRef idx="3">
+            <a:schemeClr val="accent1"/>
+          </a:fillRef>
+          <a:effectRef idx="2">
+            <a:schemeClr val="accent1"/>
+          </a:effectRef>
+          <a:fontRef idx="minor">
+            <a:schemeClr val="lt1"/>
+          </a:fontRef>
+        </p:style>
+        <p:txBody>
+          <a:bodyPr rtlCol="0" anchor="ctr" wrap="square"/>
+          <a:lstStyle/>
+          <a:p>
+            <a:pPr algn="ctr">
+              <a:defRPr sz="3400" b="1">
+                <a:solidFill>
+                  <a:srgbClr val="2E6DA4"/>
+                </a:solidFill>
+              </a:defRPr>
+            </a:pPr>
+            <a:r>
+              <a:t>0.0469</a:t>
+            </a:r>
+          </a:p>
+          <a:p>
+            <a:pPr algn="ctr">
+              <a:defRPr sz="1400">
+                <a:solidFill>
+                  <a:srgbClr val="555F6B"/>
+                </a:solidFill>
+              </a:defRPr>
+            </a:pPr>
+            <a:r>
+              <a:t>capacità (bpp)</a:t>
+            </a:r>
+          </a:p>
+        </p:txBody>
+      </p:sp>
+      <p:sp>
+        <p:nvSpPr>
+          <p:cNvPr id="7" name="Rectangle 6"/>
+          <p:cNvSpPr/>
+          <p:nvPr/>
+        </p:nvSpPr>
+        <p:spPr>
+          <a:xfrm>
+            <a:off x="9075191" y="2011680"/>
+            <a:ext cx="2567863" cy="2377440"/>
+          </a:xfrm>
+          <a:prstGeom prst="rect">
+            <a:avLst/>
+          </a:prstGeom>
+          <a:solidFill>
+            <a:srgbClr val="F2F4F6"/>
+          </a:solidFill>
+          <a:ln w="25400">
+            <a:solidFill>
+              <a:srgbClr val="2E6DA4"/>
+            </a:solidFill>
+          </a:ln>
+        </p:spPr>
+        <p:style>
+          <a:lnRef idx="1">
+            <a:schemeClr val="accent1"/>
+          </a:lnRef>
+          <a:fillRef idx="3">
+            <a:schemeClr val="accent1"/>
+          </a:fillRef>
+          <a:effectRef idx="2">
+            <a:schemeClr val="accent1"/>
+          </a:effectRef>
+          <a:fontRef idx="minor">
+            <a:schemeClr val="lt1"/>
+          </a:fontRef>
+        </p:style>
+        <p:txBody>
+          <a:bodyPr rtlCol="0" anchor="ctr" wrap="square"/>
+          <a:lstStyle/>
+          <a:p>
+            <a:pPr algn="ctr">
+              <a:defRPr sz="3400" b="1">
+                <a:solidFill>
+                  <a:srgbClr val="2E6DA4"/>
+                </a:solidFill>
+              </a:defRPr>
+            </a:pPr>
+            <a:r>
+              <a:t>0.923</a:t>
+            </a:r>
+          </a:p>
+          <a:p>
+            <a:pPr algn="ctr">
+              <a:defRPr sz="1400">
+                <a:solidFill>
+                  <a:srgbClr val="555F6B"/>
+                </a:solidFill>
+              </a:defRPr>
+            </a:pPr>
+            <a:r>
+              <a:t>NC segreto (pulito)</a:t>
             </a:r>
           </a:p>
         </p:txBody>
@@ -4150,14 +4349,14 @@
               </a:defRPr>
             </a:pPr>
             <a:r>
-              <a:t>Robustezza e compromesso capacità↔robustezza</a:t>
+              <a:t>Risultato chiave — protezione oggetti via YOLO</a:t>
             </a:r>
           </a:p>
         </p:txBody>
       </p:sp>
       <p:pic>
         <p:nvPicPr>
-          <p:cNvPr id="4" name="Picture 3" descr="fig_robustness.png"/>
+          <p:cNvPr id="4" name="Picture 3" descr="fig_object_protection.png"/>
           <p:cNvPicPr>
             <a:picLocks noChangeAspect="1"/>
           </p:cNvPicPr>
@@ -4171,8 +4370,8 @@
         </p:blipFill>
         <p:spPr>
           <a:xfrm>
-            <a:off x="700887" y="1325880"/>
-            <a:ext cx="10789920" cy="3619695"/>
+            <a:off x="457200" y="1325880"/>
+            <a:ext cx="7863840" cy="2758495"/>
           </a:xfrm>
           <a:prstGeom prst="rect">
             <a:avLst/>
@@ -4187,8 +4386,8 @@
         </p:nvSpPr>
         <p:spPr>
           <a:xfrm>
-            <a:off x="700887" y="4991295"/>
-            <a:ext cx="10789920" cy="548640"/>
+            <a:off x="457200" y="4130095"/>
+            <a:ext cx="7863840" cy="548640"/>
           </a:xfrm>
           <a:prstGeom prst="rect">
             <a:avLst/>
@@ -4209,7 +4408,75 @@
               </a:defRPr>
             </a:pPr>
             <a:r>
-              <a:t>RB resiste agli attacchi (es. JPEG-q90 NC=0.91); HC, senza ridondanza, è fragile.</a:t>
+              <a:t>PSNR oggetti: 47.40 → 50.39 dB con la guida YOLO.</a:t>
+            </a:r>
+          </a:p>
+        </p:txBody>
+      </p:sp>
+      <p:sp>
+        <p:nvSpPr>
+          <p:cNvPr id="6" name="TextBox 5"/>
+          <p:cNvSpPr txBox="1"/>
+          <p:nvPr/>
+        </p:nvSpPr>
+        <p:spPr>
+          <a:xfrm>
+            <a:off x="8412480" y="1463040"/>
+            <a:ext cx="3566160" cy="4754880"/>
+          </a:xfrm>
+          <a:prstGeom prst="rect">
+            <a:avLst/>
+          </a:prstGeom>
+          <a:noFill/>
+        </p:spPr>
+        <p:txBody>
+          <a:bodyPr wrap="square">
+            <a:spAutoFit/>
+          </a:bodyPr>
+          <a:lstStyle/>
+          <a:p>
+            <a:pPr>
+              <a:spcAft>
+                <a:spcPts val="800"/>
+              </a:spcAft>
+              <a:defRPr sz="1500">
+                <a:solidFill>
+                  <a:srgbClr val="1F3555"/>
+                </a:solidFill>
+              </a:defRPr>
+            </a:pPr>
+            <a:r>
+              <a:t>• I bit vanno nello sfondo</a:t>
+            </a:r>
+          </a:p>
+          <a:p>
+            <a:pPr>
+              <a:spcAft>
+                <a:spcPts val="800"/>
+              </a:spcAft>
+              <a:defRPr sz="1500">
+                <a:solidFill>
+                  <a:srgbClr val="1F3555"/>
+                </a:solidFill>
+              </a:defRPr>
+            </a:pPr>
+            <a:r>
+              <a:t>• Oggetti quasi intatti</a:t>
+            </a:r>
+          </a:p>
+          <a:p>
+            <a:pPr>
+              <a:spcAft>
+                <a:spcPts val="800"/>
+              </a:spcAft>
+              <a:defRPr sz="1500">
+                <a:solidFill>
+                  <a:srgbClr val="1F3555"/>
+                </a:solidFill>
+              </a:defRPr>
+            </a:pPr>
+            <a:r>
+              <a:t>• +2.99 dB sugli oggetti</a:t>
             </a:r>
           </a:p>
         </p:txBody>
@@ -4305,14 +4572,14 @@
               </a:defRPr>
             </a:pPr>
             <a:r>
-              <a:t>Fronte di Pareto</a:t>
+              <a:t>Risultato qualitativo</a:t>
             </a:r>
           </a:p>
         </p:txBody>
       </p:sp>
       <p:pic>
         <p:nvPicPr>
-          <p:cNvPr id="4" name="Picture 3" descr="fig_tradeoff.png"/>
+          <p:cNvPr id="4" name="Picture 3" descr="fig_qualitative.png"/>
           <p:cNvPicPr>
             <a:picLocks noChangeAspect="1"/>
           </p:cNvPicPr>
@@ -4326,8 +4593,8 @@
         </p:blipFill>
         <p:spPr>
           <a:xfrm>
-            <a:off x="2685606" y="1325880"/>
-            <a:ext cx="6820482" cy="4846320"/>
+            <a:off x="2186968" y="1325880"/>
+            <a:ext cx="7817758" cy="4846320"/>
           </a:xfrm>
           <a:prstGeom prst="rect">
             <a:avLst/>
@@ -4342,8 +4609,8 @@
         </p:nvSpPr>
         <p:spPr>
           <a:xfrm>
-            <a:off x="2685606" y="6217920"/>
-            <a:ext cx="6820482" cy="548640"/>
+            <a:off x="2186968" y="6217920"/>
+            <a:ext cx="7817758" cy="548640"/>
           </a:xfrm>
           <a:prstGeom prst="rect">
             <a:avLst/>
@@ -4364,7 +4631,7 @@
               </a:defRPr>
             </a:pPr>
             <a:r>
-              <a:t>Capacità (bpp) vs robustezza media (NC sotto attacco): due punti operativi.</a:t>
+              <a:t>La mappa |cover−stego| evita le regioni degli oggetti rilevati da YOLO.</a:t>
             </a:r>
           </a:p>
         </p:txBody>
@@ -4460,21 +4727,280 @@
               </a:defRPr>
             </a:pPr>
             <a:r>
-              <a:t>Conclusioni</a:t>
-            </a:r>
-          </a:p>
-        </p:txBody>
-      </p:sp>
-      <p:sp>
-        <p:nvSpPr>
-          <p:cNvPr id="4" name="TextBox 3"/>
+              <a:t>Preservazione semantica (downstream YOLO)</a:t>
+            </a:r>
+          </a:p>
+        </p:txBody>
+      </p:sp>
+      <p:sp>
+        <p:nvSpPr>
+          <p:cNvPr id="4" name="Rectangle 3"/>
+          <p:cNvSpPr/>
+          <p:nvPr/>
+        </p:nvSpPr>
+        <p:spPr>
+          <a:xfrm>
+            <a:off x="548640" y="2011680"/>
+            <a:ext cx="3515258" cy="2377440"/>
+          </a:xfrm>
+          <a:prstGeom prst="rect">
+            <a:avLst/>
+          </a:prstGeom>
+          <a:solidFill>
+            <a:srgbClr val="F2F4F6"/>
+          </a:solidFill>
+          <a:ln w="25400">
+            <a:solidFill>
+              <a:srgbClr val="2E6DA4"/>
+            </a:solidFill>
+          </a:ln>
+        </p:spPr>
+        <p:style>
+          <a:lnRef idx="1">
+            <a:schemeClr val="accent1"/>
+          </a:lnRef>
+          <a:fillRef idx="3">
+            <a:schemeClr val="accent1"/>
+          </a:fillRef>
+          <a:effectRef idx="2">
+            <a:schemeClr val="accent1"/>
+          </a:effectRef>
+          <a:fontRef idx="minor">
+            <a:schemeClr val="lt1"/>
+          </a:fontRef>
+        </p:style>
+        <p:txBody>
+          <a:bodyPr rtlCol="0" anchor="ctr" wrap="square"/>
+          <a:lstStyle/>
+          <a:p>
+            <a:pPr algn="ctr">
+              <a:defRPr sz="3400" b="1">
+                <a:solidFill>
+                  <a:srgbClr val="2E6DA4"/>
+                </a:solidFill>
+              </a:defRPr>
+            </a:pPr>
+            <a:r>
+              <a:t>0.961</a:t>
+            </a:r>
+          </a:p>
+          <a:p>
+            <a:pPr algn="ctr">
+              <a:defRPr sz="1400">
+                <a:solidFill>
+                  <a:srgbClr val="555F6B"/>
+                </a:solidFill>
+              </a:defRPr>
+            </a:pPr>
+            <a:r>
+              <a:t>preservation rate</a:t>
+            </a:r>
+          </a:p>
+        </p:txBody>
+      </p:sp>
+      <p:sp>
+        <p:nvSpPr>
+          <p:cNvPr id="5" name="Rectangle 4"/>
+          <p:cNvSpPr/>
+          <p:nvPr/>
+        </p:nvSpPr>
+        <p:spPr>
+          <a:xfrm>
+            <a:off x="4338218" y="2011680"/>
+            <a:ext cx="3515258" cy="2377440"/>
+          </a:xfrm>
+          <a:prstGeom prst="rect">
+            <a:avLst/>
+          </a:prstGeom>
+          <a:solidFill>
+            <a:srgbClr val="F2F4F6"/>
+          </a:solidFill>
+          <a:ln w="25400">
+            <a:solidFill>
+              <a:srgbClr val="2E6DA4"/>
+            </a:solidFill>
+          </a:ln>
+        </p:spPr>
+        <p:style>
+          <a:lnRef idx="1">
+            <a:schemeClr val="accent1"/>
+          </a:lnRef>
+          <a:fillRef idx="3">
+            <a:schemeClr val="accent1"/>
+          </a:fillRef>
+          <a:effectRef idx="2">
+            <a:schemeClr val="accent1"/>
+          </a:effectRef>
+          <a:fontRef idx="minor">
+            <a:schemeClr val="lt1"/>
+          </a:fontRef>
+        </p:style>
+        <p:txBody>
+          <a:bodyPr rtlCol="0" anchor="ctr" wrap="square"/>
+          <a:lstStyle/>
+          <a:p>
+            <a:pPr algn="ctr">
+              <a:defRPr sz="3400" b="1">
+                <a:solidFill>
+                  <a:srgbClr val="2E6DA4"/>
+                </a:solidFill>
+              </a:defRPr>
+            </a:pPr>
+            <a:r>
+              <a:t>0.959</a:t>
+            </a:r>
+          </a:p>
+          <a:p>
+            <a:pPr algn="ctr">
+              <a:defRPr sz="1400">
+                <a:solidFill>
+                  <a:srgbClr val="555F6B"/>
+                </a:solidFill>
+              </a:defRPr>
+            </a:pPr>
+            <a:r>
+              <a:t>mAP@0.5 stego vs cover</a:t>
+            </a:r>
+          </a:p>
+        </p:txBody>
+      </p:sp>
+      <p:sp>
+        <p:nvSpPr>
+          <p:cNvPr id="6" name="Rectangle 5"/>
+          <p:cNvSpPr/>
+          <p:nvPr/>
+        </p:nvSpPr>
+        <p:spPr>
+          <a:xfrm>
+            <a:off x="8127796" y="2011680"/>
+            <a:ext cx="3515258" cy="2377440"/>
+          </a:xfrm>
+          <a:prstGeom prst="rect">
+            <a:avLst/>
+          </a:prstGeom>
+          <a:solidFill>
+            <a:srgbClr val="F2F4F6"/>
+          </a:solidFill>
+          <a:ln w="25400">
+            <a:solidFill>
+              <a:srgbClr val="2E6DA4"/>
+            </a:solidFill>
+          </a:ln>
+        </p:spPr>
+        <p:style>
+          <a:lnRef idx="1">
+            <a:schemeClr val="accent1"/>
+          </a:lnRef>
+          <a:fillRef idx="3">
+            <a:schemeClr val="accent1"/>
+          </a:fillRef>
+          <a:effectRef idx="2">
+            <a:schemeClr val="accent1"/>
+          </a:effectRef>
+          <a:fontRef idx="minor">
+            <a:schemeClr val="lt1"/>
+          </a:fontRef>
+        </p:style>
+        <p:txBody>
+          <a:bodyPr rtlCol="0" anchor="ctr" wrap="square"/>
+          <a:lstStyle/>
+          <a:p>
+            <a:pPr algn="ctr">
+              <a:defRPr sz="3400" b="1">
+                <a:solidFill>
+                  <a:srgbClr val="2E6DA4"/>
+                </a:solidFill>
+              </a:defRPr>
+            </a:pPr>
+            <a:r>
+              <a:t>0.016</a:t>
+            </a:r>
+          </a:p>
+          <a:p>
+            <a:pPr algn="ctr">
+              <a:defRPr sz="1400">
+                <a:solidFill>
+                  <a:srgbClr val="555F6B"/>
+                </a:solidFill>
+              </a:defRPr>
+            </a:pPr>
+            <a:r>
+              <a:t>|Δ confidenza| medio</a:t>
+            </a:r>
+          </a:p>
+        </p:txBody>
+      </p:sp>
+    </p:spTree>
+  </p:cSld>
+  <p:clrMapOvr>
+    <a:masterClrMapping/>
+  </p:clrMapOvr>
+</p:sld>
+</file>
+
+<file path=ppt/slides/slide17.xml><?xml version="1.0" encoding="utf-8"?>
+<p:sld xmlns:a="http://schemas.openxmlformats.org/drawingml/2006/main" xmlns:p="http://schemas.openxmlformats.org/presentationml/2006/main" xmlns:r="http://schemas.openxmlformats.org/officeDocument/2006/relationships">
+  <p:cSld>
+    <p:spTree>
+      <p:nvGrpSpPr>
+        <p:cNvPr id="1" name=""/>
+        <p:cNvGrpSpPr/>
+        <p:nvPr/>
+      </p:nvGrpSpPr>
+      <p:grpSpPr/>
+      <p:sp>
+        <p:nvSpPr>
+          <p:cNvPr id="2" name="Rectangle 1"/>
+          <p:cNvSpPr/>
+          <p:nvPr/>
+        </p:nvSpPr>
+        <p:spPr>
+          <a:xfrm>
+            <a:off x="0" y="0"/>
+            <a:ext cx="12191695" cy="1051560"/>
+          </a:xfrm>
+          <a:prstGeom prst="rect">
+            <a:avLst/>
+          </a:prstGeom>
+          <a:solidFill>
+            <a:srgbClr val="1F3555"/>
+          </a:solidFill>
+          <a:ln>
+            <a:noFill/>
+          </a:ln>
+        </p:spPr>
+        <p:style>
+          <a:lnRef idx="1">
+            <a:schemeClr val="accent1"/>
+          </a:lnRef>
+          <a:fillRef idx="3">
+            <a:schemeClr val="accent1"/>
+          </a:fillRef>
+          <a:effectRef idx="2">
+            <a:schemeClr val="accent1"/>
+          </a:effectRef>
+          <a:fontRef idx="minor">
+            <a:schemeClr val="lt1"/>
+          </a:fontRef>
+        </p:style>
+        <p:txBody>
+          <a:bodyPr rtlCol="0" anchor="ctr"/>
+          <a:lstStyle/>
+          <a:p>
+            <a:pPr algn="ctr"/>
+          </a:p>
+        </p:txBody>
+      </p:sp>
+      <p:sp>
+        <p:nvSpPr>
+          <p:cNvPr id="3" name="TextBox 2"/>
           <p:cNvSpPr txBox="1"/>
           <p:nvPr/>
         </p:nvSpPr>
         <p:spPr>
           <a:xfrm>
-            <a:off x="640080" y="1371600"/>
-            <a:ext cx="10972800" cy="4754880"/>
+            <a:off x="548640" y="164592"/>
+            <a:ext cx="10972800" cy="822960"/>
           </a:xfrm>
           <a:prstGeom prst="rect">
             <a:avLst/>
@@ -4488,77 +5014,383 @@
           <a:lstStyle/>
           <a:p>
             <a:pPr>
-              <a:spcAft>
-                <a:spcPts val="800"/>
-              </a:spcAft>
-              <a:defRPr sz="2000">
-                <a:solidFill>
-                  <a:srgbClr val="1F3555"/>
-                </a:solidFill>
-              </a:defRPr>
-            </a:pPr>
-            <a:r>
-              <a:t>• La SVD fornisce un quadro unificato: compressione del segreto (Eckart–Young), dominio di embedding robusto (σ₁), analisi del condizionamento.</a:t>
-            </a:r>
-          </a:p>
+              <a:defRPr sz="2800" b="1">
+                <a:solidFill>
+                  <a:srgbClr val="FFFFFF"/>
+                </a:solidFill>
+              </a:defRPr>
+            </a:pPr>
+            <a:r>
+              <a:t>Recupero del segreto e compressione</a:t>
+            </a:r>
+          </a:p>
+        </p:txBody>
+      </p:sp>
+      <p:pic>
+        <p:nvPicPr>
+          <p:cNvPr id="4" name="Picture 3" descr="fig_secret_compression.png"/>
+          <p:cNvPicPr>
+            <a:picLocks noChangeAspect="1"/>
+          </p:cNvPicPr>
+          <p:nvPr/>
+        </p:nvPicPr>
+        <p:blipFill>
+          <a:blip r:embed="rId2"/>
+          <a:stretch>
+            <a:fillRect/>
+          </a:stretch>
+        </p:blipFill>
+        <p:spPr>
+          <a:xfrm>
+            <a:off x="700887" y="1325880"/>
+            <a:ext cx="10789920" cy="3784911"/>
+          </a:xfrm>
+          <a:prstGeom prst="rect">
+            <a:avLst/>
+          </a:prstGeom>
+        </p:spPr>
+      </p:pic>
+      <p:sp>
+        <p:nvSpPr>
+          <p:cNvPr id="5" name="TextBox 4"/>
+          <p:cNvSpPr txBox="1"/>
+          <p:nvPr/>
+        </p:nvSpPr>
+        <p:spPr>
+          <a:xfrm>
+            <a:off x="700887" y="5156511"/>
+            <a:ext cx="10789920" cy="548640"/>
+          </a:xfrm>
+          <a:prstGeom prst="rect">
+            <a:avLst/>
+          </a:prstGeom>
+          <a:noFill/>
+        </p:spPr>
+        <p:txBody>
+          <a:bodyPr wrap="square">
+            <a:spAutoFit/>
+          </a:bodyPr>
+          <a:lstStyle/>
+          <a:p>
+            <a:pPr algn="ctr">
+              <a:defRPr sz="1100" i="1">
+                <a:solidFill>
+                  <a:srgbClr val="555F6B"/>
+                </a:solidFill>
+              </a:defRPr>
+            </a:pPr>
+            <a:r>
+              <a:t>Il limite in pulito è dato dalla compressione SVD del segreto, non dall'estrazione.</a:t>
+            </a:r>
+          </a:p>
+        </p:txBody>
+      </p:sp>
+    </p:spTree>
+  </p:cSld>
+  <p:clrMapOvr>
+    <a:masterClrMapping/>
+  </p:clrMapOvr>
+</p:sld>
+</file>
+
+<file path=ppt/slides/slide18.xml><?xml version="1.0" encoding="utf-8"?>
+<p:sld xmlns:a="http://schemas.openxmlformats.org/drawingml/2006/main" xmlns:p="http://schemas.openxmlformats.org/presentationml/2006/main" xmlns:r="http://schemas.openxmlformats.org/officeDocument/2006/relationships">
+  <p:cSld>
+    <p:spTree>
+      <p:nvGrpSpPr>
+        <p:cNvPr id="1" name=""/>
+        <p:cNvGrpSpPr/>
+        <p:nvPr/>
+      </p:nvGrpSpPr>
+      <p:grpSpPr/>
+      <p:sp>
+        <p:nvSpPr>
+          <p:cNvPr id="2" name="Rectangle 1"/>
+          <p:cNvSpPr/>
+          <p:nvPr/>
+        </p:nvSpPr>
+        <p:spPr>
+          <a:xfrm>
+            <a:off x="0" y="0"/>
+            <a:ext cx="12191695" cy="1051560"/>
+          </a:xfrm>
+          <a:prstGeom prst="rect">
+            <a:avLst/>
+          </a:prstGeom>
+          <a:solidFill>
+            <a:srgbClr val="1F3555"/>
+          </a:solidFill>
+          <a:ln>
+            <a:noFill/>
+          </a:ln>
+        </p:spPr>
+        <p:style>
+          <a:lnRef idx="1">
+            <a:schemeClr val="accent1"/>
+          </a:lnRef>
+          <a:fillRef idx="3">
+            <a:schemeClr val="accent1"/>
+          </a:fillRef>
+          <a:effectRef idx="2">
+            <a:schemeClr val="accent1"/>
+          </a:effectRef>
+          <a:fontRef idx="minor">
+            <a:schemeClr val="lt1"/>
+          </a:fontRef>
+        </p:style>
+        <p:txBody>
+          <a:bodyPr rtlCol="0" anchor="ctr"/>
+          <a:lstStyle/>
+          <a:p>
+            <a:pPr algn="ctr"/>
+          </a:p>
+        </p:txBody>
+      </p:sp>
+      <p:sp>
+        <p:nvSpPr>
+          <p:cNvPr id="3" name="TextBox 2"/>
+          <p:cNvSpPr txBox="1"/>
+          <p:nvPr/>
+        </p:nvSpPr>
+        <p:spPr>
+          <a:xfrm>
+            <a:off x="548640" y="164592"/>
+            <a:ext cx="10972800" cy="822960"/>
+          </a:xfrm>
+          <a:prstGeom prst="rect">
+            <a:avLst/>
+          </a:prstGeom>
+          <a:noFill/>
+        </p:spPr>
+        <p:txBody>
+          <a:bodyPr wrap="square">
+            <a:spAutoFit/>
+          </a:bodyPr>
+          <a:lstStyle/>
           <a:p>
             <a:pPr>
-              <a:spcAft>
-                <a:spcPts val="800"/>
-              </a:spcAft>
-              <a:defRPr sz="2000">
-                <a:solidFill>
-                  <a:srgbClr val="1F3555"/>
-                </a:solidFill>
-              </a:defRPr>
-            </a:pPr>
-            <a:r>
-              <a:t>• Impercettibilità elevata (PSNR ≈ 47.39 dB) e preservazione semantica quasi perfetta (mAP ≈ 0.96).</a:t>
-            </a:r>
-          </a:p>
+              <a:defRPr sz="2800" b="1">
+                <a:solidFill>
+                  <a:srgbClr val="FFFFFF"/>
+                </a:solidFill>
+              </a:defRPr>
+            </a:pPr>
+            <a:r>
+              <a:t>Robustezza e compromesso capacità↔robustezza</a:t>
+            </a:r>
+          </a:p>
+        </p:txBody>
+      </p:sp>
+      <p:pic>
+        <p:nvPicPr>
+          <p:cNvPr id="4" name="Picture 3" descr="fig_robustness.png"/>
+          <p:cNvPicPr>
+            <a:picLocks noChangeAspect="1"/>
+          </p:cNvPicPr>
+          <p:nvPr/>
+        </p:nvPicPr>
+        <p:blipFill>
+          <a:blip r:embed="rId2"/>
+          <a:stretch>
+            <a:fillRect/>
+          </a:stretch>
+        </p:blipFill>
+        <p:spPr>
+          <a:xfrm>
+            <a:off x="700887" y="1325880"/>
+            <a:ext cx="10789920" cy="3619695"/>
+          </a:xfrm>
+          <a:prstGeom prst="rect">
+            <a:avLst/>
+          </a:prstGeom>
+        </p:spPr>
+      </p:pic>
+      <p:sp>
+        <p:nvSpPr>
+          <p:cNvPr id="5" name="TextBox 4"/>
+          <p:cNvSpPr txBox="1"/>
+          <p:nvPr/>
+        </p:nvSpPr>
+        <p:spPr>
+          <a:xfrm>
+            <a:off x="700887" y="4991295"/>
+            <a:ext cx="10789920" cy="548640"/>
+          </a:xfrm>
+          <a:prstGeom prst="rect">
+            <a:avLst/>
+          </a:prstGeom>
+          <a:noFill/>
+        </p:spPr>
+        <p:txBody>
+          <a:bodyPr wrap="square">
+            <a:spAutoFit/>
+          </a:bodyPr>
+          <a:lstStyle/>
+          <a:p>
+            <a:pPr algn="ctr">
+              <a:defRPr sz="1100" i="1">
+                <a:solidFill>
+                  <a:srgbClr val="555F6B"/>
+                </a:solidFill>
+              </a:defRPr>
+            </a:pPr>
+            <a:r>
+              <a:t>RB resiste agli attacchi (es. JPEG-q90 NC=0.91); HC, senza ridondanza, è fragile.</a:t>
+            </a:r>
+          </a:p>
+        </p:txBody>
+      </p:sp>
+    </p:spTree>
+  </p:cSld>
+  <p:clrMapOvr>
+    <a:masterClrMapping/>
+  </p:clrMapOvr>
+</p:sld>
+</file>
+
+<file path=ppt/slides/slide19.xml><?xml version="1.0" encoding="utf-8"?>
+<p:sld xmlns:a="http://schemas.openxmlformats.org/drawingml/2006/main" xmlns:p="http://schemas.openxmlformats.org/presentationml/2006/main" xmlns:r="http://schemas.openxmlformats.org/officeDocument/2006/relationships">
+  <p:cSld>
+    <p:spTree>
+      <p:nvGrpSpPr>
+        <p:cNvPr id="1" name=""/>
+        <p:cNvGrpSpPr/>
+        <p:nvPr/>
+      </p:nvGrpSpPr>
+      <p:grpSpPr/>
+      <p:sp>
+        <p:nvSpPr>
+          <p:cNvPr id="2" name="Rectangle 1"/>
+          <p:cNvSpPr/>
+          <p:nvPr/>
+        </p:nvSpPr>
+        <p:spPr>
+          <a:xfrm>
+            <a:off x="0" y="0"/>
+            <a:ext cx="12191695" cy="1051560"/>
+          </a:xfrm>
+          <a:prstGeom prst="rect">
+            <a:avLst/>
+          </a:prstGeom>
+          <a:solidFill>
+            <a:srgbClr val="1F3555"/>
+          </a:solidFill>
+          <a:ln>
+            <a:noFill/>
+          </a:ln>
+        </p:spPr>
+        <p:style>
+          <a:lnRef idx="1">
+            <a:schemeClr val="accent1"/>
+          </a:lnRef>
+          <a:fillRef idx="3">
+            <a:schemeClr val="accent1"/>
+          </a:fillRef>
+          <a:effectRef idx="2">
+            <a:schemeClr val="accent1"/>
+          </a:effectRef>
+          <a:fontRef idx="minor">
+            <a:schemeClr val="lt1"/>
+          </a:fontRef>
+        </p:style>
+        <p:txBody>
+          <a:bodyPr rtlCol="0" anchor="ctr"/>
+          <a:lstStyle/>
+          <a:p>
+            <a:pPr algn="ctr"/>
+          </a:p>
+        </p:txBody>
+      </p:sp>
+      <p:sp>
+        <p:nvSpPr>
+          <p:cNvPr id="3" name="TextBox 2"/>
+          <p:cNvSpPr txBox="1"/>
+          <p:nvPr/>
+        </p:nvSpPr>
+        <p:spPr>
+          <a:xfrm>
+            <a:off x="548640" y="164592"/>
+            <a:ext cx="10972800" cy="822960"/>
+          </a:xfrm>
+          <a:prstGeom prst="rect">
+            <a:avLst/>
+          </a:prstGeom>
+          <a:noFill/>
+        </p:spPr>
+        <p:txBody>
+          <a:bodyPr wrap="square">
+            <a:spAutoFit/>
+          </a:bodyPr>
+          <a:lstStyle/>
           <a:p>
             <a:pPr>
-              <a:spcAft>
-                <a:spcPts val="800"/>
-              </a:spcAft>
-              <a:defRPr sz="2000">
-                <a:solidFill>
-                  <a:srgbClr val="1F3555"/>
-                </a:solidFill>
-              </a:defRPr>
-            </a:pPr>
-            <a:r>
-              <a:t>• La guida YOLO protegge le regioni salienti (+~10 dB) a parità di capacità.</a:t>
-            </a:r>
-          </a:p>
-          <a:p>
-            <a:pPr>
-              <a:spcAft>
-                <a:spcPts val="800"/>
-              </a:spcAft>
-              <a:defRPr sz="2000">
-                <a:solidFill>
-                  <a:srgbClr val="1F3555"/>
-                </a:solidFill>
-              </a:defRPr>
-            </a:pPr>
-            <a:r>
-              <a:t>• Compromesso capacità↔robustezza governato da tre leve SVD: dimensione blocco, passo Δ, ridondanza R.</a:t>
-            </a:r>
-          </a:p>
-          <a:p>
-            <a:pPr>
-              <a:spcAft>
-                <a:spcPts val="800"/>
-              </a:spcAft>
-              <a:defRPr sz="2000">
-                <a:solidFill>
-                  <a:srgbClr val="1F3555"/>
-                </a:solidFill>
-              </a:defRPr>
-            </a:pPr>
-            <a:r>
-              <a:t>• Codice e documentazione completi, riproducibili su 100+ immagini COCO.</a:t>
+              <a:defRPr sz="2800" b="1">
+                <a:solidFill>
+                  <a:srgbClr val="FFFFFF"/>
+                </a:solidFill>
+              </a:defRPr>
+            </a:pPr>
+            <a:r>
+              <a:t>Fronte di Pareto</a:t>
+            </a:r>
+          </a:p>
+        </p:txBody>
+      </p:sp>
+      <p:pic>
+        <p:nvPicPr>
+          <p:cNvPr id="4" name="Picture 3" descr="fig_tradeoff.png"/>
+          <p:cNvPicPr>
+            <a:picLocks noChangeAspect="1"/>
+          </p:cNvPicPr>
+          <p:nvPr/>
+        </p:nvPicPr>
+        <p:blipFill>
+          <a:blip r:embed="rId2"/>
+          <a:stretch>
+            <a:fillRect/>
+          </a:stretch>
+        </p:blipFill>
+        <p:spPr>
+          <a:xfrm>
+            <a:off x="2685606" y="1325880"/>
+            <a:ext cx="6820482" cy="4846320"/>
+          </a:xfrm>
+          <a:prstGeom prst="rect">
+            <a:avLst/>
+          </a:prstGeom>
+        </p:spPr>
+      </p:pic>
+      <p:sp>
+        <p:nvSpPr>
+          <p:cNvPr id="5" name="TextBox 4"/>
+          <p:cNvSpPr txBox="1"/>
+          <p:nvPr/>
+        </p:nvSpPr>
+        <p:spPr>
+          <a:xfrm>
+            <a:off x="2685606" y="6217920"/>
+            <a:ext cx="6820482" cy="548640"/>
+          </a:xfrm>
+          <a:prstGeom prst="rect">
+            <a:avLst/>
+          </a:prstGeom>
+          <a:noFill/>
+        </p:spPr>
+        <p:txBody>
+          <a:bodyPr wrap="square">
+            <a:spAutoFit/>
+          </a:bodyPr>
+          <a:lstStyle/>
+          <a:p>
+            <a:pPr algn="ctr">
+              <a:defRPr sz="1100" i="1">
+                <a:solidFill>
+                  <a:srgbClr val="555F6B"/>
+                </a:solidFill>
+              </a:defRPr>
+            </a:pPr>
+            <a:r>
+              <a:t>Capacità (bpp) vs robustezza media (NC sotto attacco): due punti operativi.</a:t>
             </a:r>
           </a:p>
         </p:txBody>
@@ -4780,6 +5612,215 @@
 </p:sld>
 </file>
 
+<file path=ppt/slides/slide20.xml><?xml version="1.0" encoding="utf-8"?>
+<p:sld xmlns:a="http://schemas.openxmlformats.org/drawingml/2006/main" xmlns:p="http://schemas.openxmlformats.org/presentationml/2006/main" xmlns:r="http://schemas.openxmlformats.org/officeDocument/2006/relationships">
+  <p:cSld>
+    <p:spTree>
+      <p:nvGrpSpPr>
+        <p:cNvPr id="1" name=""/>
+        <p:cNvGrpSpPr/>
+        <p:nvPr/>
+      </p:nvGrpSpPr>
+      <p:grpSpPr/>
+      <p:sp>
+        <p:nvSpPr>
+          <p:cNvPr id="2" name="Rectangle 1"/>
+          <p:cNvSpPr/>
+          <p:nvPr/>
+        </p:nvSpPr>
+        <p:spPr>
+          <a:xfrm>
+            <a:off x="0" y="0"/>
+            <a:ext cx="12191695" cy="1051560"/>
+          </a:xfrm>
+          <a:prstGeom prst="rect">
+            <a:avLst/>
+          </a:prstGeom>
+          <a:solidFill>
+            <a:srgbClr val="1F3555"/>
+          </a:solidFill>
+          <a:ln>
+            <a:noFill/>
+          </a:ln>
+        </p:spPr>
+        <p:style>
+          <a:lnRef idx="1">
+            <a:schemeClr val="accent1"/>
+          </a:lnRef>
+          <a:fillRef idx="3">
+            <a:schemeClr val="accent1"/>
+          </a:fillRef>
+          <a:effectRef idx="2">
+            <a:schemeClr val="accent1"/>
+          </a:effectRef>
+          <a:fontRef idx="minor">
+            <a:schemeClr val="lt1"/>
+          </a:fontRef>
+        </p:style>
+        <p:txBody>
+          <a:bodyPr rtlCol="0" anchor="ctr"/>
+          <a:lstStyle/>
+          <a:p>
+            <a:pPr algn="ctr"/>
+          </a:p>
+        </p:txBody>
+      </p:sp>
+      <p:sp>
+        <p:nvSpPr>
+          <p:cNvPr id="3" name="TextBox 2"/>
+          <p:cNvSpPr txBox="1"/>
+          <p:nvPr/>
+        </p:nvSpPr>
+        <p:spPr>
+          <a:xfrm>
+            <a:off x="548640" y="164592"/>
+            <a:ext cx="10972800" cy="822960"/>
+          </a:xfrm>
+          <a:prstGeom prst="rect">
+            <a:avLst/>
+          </a:prstGeom>
+          <a:noFill/>
+        </p:spPr>
+        <p:txBody>
+          <a:bodyPr wrap="square">
+            <a:spAutoFit/>
+          </a:bodyPr>
+          <a:lstStyle/>
+          <a:p>
+            <a:pPr>
+              <a:defRPr sz="2800" b="1">
+                <a:solidFill>
+                  <a:srgbClr val="FFFFFF"/>
+                </a:solidFill>
+              </a:defRPr>
+            </a:pPr>
+            <a:r>
+              <a:t>Conclusioni</a:t>
+            </a:r>
+          </a:p>
+        </p:txBody>
+      </p:sp>
+      <p:sp>
+        <p:nvSpPr>
+          <p:cNvPr id="4" name="TextBox 3"/>
+          <p:cNvSpPr txBox="1"/>
+          <p:nvPr/>
+        </p:nvSpPr>
+        <p:spPr>
+          <a:xfrm>
+            <a:off x="640080" y="1371600"/>
+            <a:ext cx="10972800" cy="4754880"/>
+          </a:xfrm>
+          <a:prstGeom prst="rect">
+            <a:avLst/>
+          </a:prstGeom>
+          <a:noFill/>
+        </p:spPr>
+        <p:txBody>
+          <a:bodyPr wrap="square">
+            <a:spAutoFit/>
+          </a:bodyPr>
+          <a:lstStyle/>
+          <a:p>
+            <a:pPr>
+              <a:spcAft>
+                <a:spcPts val="800"/>
+              </a:spcAft>
+              <a:defRPr sz="2000">
+                <a:solidFill>
+                  <a:srgbClr val="1F3555"/>
+                </a:solidFill>
+              </a:defRPr>
+            </a:pPr>
+            <a:r>
+              <a:t>• La SVD fornisce un quadro unificato: compressione del segreto (Eckart–Young), dominio di embedding robusto (σ₁), analisi del condizionamento.</a:t>
+            </a:r>
+          </a:p>
+          <a:p>
+            <a:pPr>
+              <a:spcAft>
+                <a:spcPts val="800"/>
+              </a:spcAft>
+              <a:defRPr sz="2000">
+                <a:solidFill>
+                  <a:srgbClr val="1F3555"/>
+                </a:solidFill>
+              </a:defRPr>
+            </a:pPr>
+            <a:r>
+              <a:t>• Impercettibilità elevata (PSNR ≈ 47.39 dB) e preservazione semantica quasi perfetta (mAP ≈ 0.96).</a:t>
+            </a:r>
+          </a:p>
+          <a:p>
+            <a:pPr>
+              <a:spcAft>
+                <a:spcPts val="800"/>
+              </a:spcAft>
+              <a:defRPr sz="2000">
+                <a:solidFill>
+                  <a:srgbClr val="1F3555"/>
+                </a:solidFill>
+              </a:defRPr>
+            </a:pPr>
+            <a:r>
+              <a:t>• La guida YOLO protegge le regioni salienti (+3.0 dB sugli oggetti) a parità di capacità.</a:t>
+            </a:r>
+          </a:p>
+          <a:p>
+            <a:pPr>
+              <a:spcAft>
+                <a:spcPts val="800"/>
+              </a:spcAft>
+              <a:defRPr sz="2000">
+                <a:solidFill>
+                  <a:srgbClr val="1F3555"/>
+                </a:solidFill>
+              </a:defRPr>
+            </a:pPr>
+            <a:r>
+              <a:t>• PSNR e robustezza previsti dalla teoria (E[δ²]=7Δ²/48, Weyl ‖E‖₂&lt;Δ/4): scarto teoria–misura &lt; 0.3 dB.</a:t>
+            </a:r>
+          </a:p>
+          <a:p>
+            <a:pPr>
+              <a:spcAft>
+                <a:spcPts val="800"/>
+              </a:spcAft>
+              <a:defRPr sz="2000">
+                <a:solidFill>
+                  <a:srgbClr val="1F3555"/>
+                </a:solidFill>
+              </a:defRPr>
+            </a:pPr>
+            <a:r>
+              <a:t>• Compromesso capacità↔robustezza governato da tre leve SVD: dimensione blocco, passo Δ, ridondanza R — tutte motivate teoricamente.</a:t>
+            </a:r>
+          </a:p>
+          <a:p>
+            <a:pPr>
+              <a:spcAft>
+                <a:spcPts val="800"/>
+              </a:spcAft>
+              <a:defRPr sz="2000">
+                <a:solidFill>
+                  <a:srgbClr val="1F3555"/>
+                </a:solidFill>
+              </a:defRPr>
+            </a:pPr>
+            <a:r>
+              <a:t>• Codice e documentazione completi, riproducibili su 100+ immagini COCO.</a:t>
+            </a:r>
+          </a:p>
+        </p:txBody>
+      </p:sp>
+    </p:spTree>
+  </p:cSld>
+  <p:clrMapOvr>
+    <a:masterClrMapping/>
+  </p:clrMapOvr>
+</p:sld>
+</file>
+
 <file path=ppt/slides/slide3.xml><?xml version="1.0" encoding="utf-8"?>
 <p:sld xmlns:a="http://schemas.openxmlformats.org/drawingml/2006/main" xmlns:p="http://schemas.openxmlformats.org/presentationml/2006/main" xmlns:r="http://schemas.openxmlformats.org/officeDocument/2006/relationships">
   <p:cSld>
@@ -5664,7 +6705,7 @@
               </a:defRPr>
             </a:pPr>
             <a:r>
-              <a:t>Embedding nel dominio SVD (QIM su σ₁)</a:t>
+              <a:t>Perché proprio i valori singolari (e perché σ₁)</a:t>
             </a:r>
           </a:p>
         </p:txBody>
@@ -5677,7 +6718,42 @@
         </p:nvSpPr>
         <p:spPr>
           <a:xfrm>
-            <a:off x="640080" y="1371600"/>
+            <a:off x="640080" y="1143000"/>
+            <a:ext cx="10972800" cy="457200"/>
+          </a:xfrm>
+          <a:prstGeom prst="rect">
+            <a:avLst/>
+          </a:prstGeom>
+          <a:noFill/>
+        </p:spPr>
+        <p:txBody>
+          <a:bodyPr wrap="square">
+            <a:spAutoFit/>
+          </a:bodyPr>
+          <a:lstStyle/>
+          <a:p>
+            <a:pPr>
+              <a:defRPr sz="1500" i="1">
+                <a:solidFill>
+                  <a:srgbClr val="555F6B"/>
+                </a:solidFill>
+              </a:defRPr>
+            </a:pPr>
+            <a:r>
+              <a:t>Il punto sollevato dalla teoria del corso: piccoli σ = componenti instabili</a:t>
+            </a:r>
+          </a:p>
+        </p:txBody>
+      </p:sp>
+      <p:sp>
+        <p:nvSpPr>
+          <p:cNvPr id="5" name="TextBox 4"/>
+          <p:cNvSpPr txBox="1"/>
+          <p:nvPr/>
+        </p:nvSpPr>
+        <p:spPr>
+          <a:xfrm>
+            <a:off x="640080" y="1783080"/>
             <a:ext cx="10972800" cy="4754880"/>
           </a:xfrm>
           <a:prstGeom prst="rect">
@@ -5702,7 +6778,7 @@
               </a:defRPr>
             </a:pPr>
             <a:r>
-              <a:t>• Per ogni blocco B×B: A = UΣVᵀ; si codifica un bit in σ₁ con passo Δ (Quantisation Index Modulation).</a:t>
+              <a:t>• Concentrazione di energia (Eckart–Young): nei blocchi naturali σ₁² raccoglie il 95–99 % di ‖A‖_F² = Σσᵢ² ⇒ σ₁ è la coordinata più significativa del blocco nella base {uᵢvᵢᵀ}.</a:t>
             </a:r>
           </a:p>
           <a:p>
@@ -5717,7 +6793,7 @@
               </a:defRPr>
             </a:pPr>
             <a:r>
-              <a:t>• σ₁' = ⌊σ₁/Δ⌋·Δ + (0.25 o 0.75)·Δ  a seconda del bit.</a:t>
+              <a:t>• Stabilità (Weyl): una perturbazione E sposta tutti i σᵢ di ≤ ‖E‖₂ in assoluto ⇒ perturbazione relativa minima su σ₁, enorme sui σᵢ piccoli (che 'amplificano il rumore', come visto a lezione).</a:t>
             </a:r>
           </a:p>
           <a:p>
@@ -5732,7 +6808,7 @@
               </a:defRPr>
             </a:pPr>
             <a:r>
-              <a:t>• Distorsione: ‖δ·u₁v₁ᵀ‖_F = |δ|, distribuita su tutto il blocco ⇒ impercettibile per pixel.</a:t>
+              <a:t>• Invarianza: i σᵢ non cambiano per trasformazioni ortogonali del blocco — descrittore intrinseco dell'energia.</a:t>
             </a:r>
           </a:p>
           <a:p>
@@ -5747,22 +6823,7 @@
               </a:defRPr>
             </a:pPr>
             <a:r>
-              <a:t>• Decodifica cieca dalla parte frazionaria di σ₁/Δ; margine di robustezza Δ/4.</a:t>
-            </a:r>
-          </a:p>
-          <a:p>
-            <a:pPr>
-              <a:spcAft>
-                <a:spcPts val="800"/>
-              </a:spcAft>
-              <a:defRPr sz="2000">
-                <a:solidFill>
-                  <a:srgbClr val="1F3555"/>
-                </a:solidFill>
-              </a:defRPr>
-            </a:pPr>
-            <a:r>
-              <a:t>• Codice a ripetizione (×R) + voto di maggioranza per la robustezza.</a:t>
+              <a:t>• Distorsione distribuita: variare σ₁ di δ cambia il blocco di δ·u₁v₁ᵀ, norma |δ| spalmata su B² pixel lungo la componente più liscia; toccare un σᵢ piccolo inietterebbe rumore ad alta frequenza, visibile.</a:t>
             </a:r>
           </a:p>
         </p:txBody>
@@ -5858,7 +6919,7 @@
               </a:defRPr>
             </a:pPr>
             <a:r>
-              <a:t>Setup sperimentale</a:t>
+              <a:t>Embedding nel dominio SVD (QIM su σ₁)</a:t>
             </a:r>
           </a:p>
         </p:txBody>
@@ -5896,7 +6957,7 @@
               </a:defRPr>
             </a:pPr>
             <a:r>
-              <a:t>• Dataset: COCO-128 — 128 immagini reali di COCO, cover 512×512.</a:t>
+              <a:t>• Serializzazione: header 9 byte (magic, h, w, k) + σ in float16 + U_k, V_kᵀ in int8 (norma unitaria ⇒ elementi in [−1,1], scala fissa 127).</a:t>
             </a:r>
           </a:p>
           <a:p>
@@ -5911,7 +6972,22 @@
               </a:defRPr>
             </a:pPr>
             <a:r>
-              <a:t>• Due punti operativi:</a:t>
+              <a:t>• Ordine dei blocchi: chiave PRNG + mappa di priorità YOLO (sfondo prima).</a:t>
+            </a:r>
+          </a:p>
+          <a:p>
+            <a:pPr>
+              <a:spcAft>
+                <a:spcPts val="800"/>
+              </a:spcAft>
+              <a:defRPr sz="2000">
+                <a:solidFill>
+                  <a:srgbClr val="1F3555"/>
+                </a:solidFill>
+              </a:defRPr>
+            </a:pPr>
+            <a:r>
+              <a:t>• Per ogni blocco B×B: A = UΣVᵀ; un bit in σ₁ con passo Δ:</a:t>
             </a:r>
           </a:p>
           <a:p>
@@ -5926,7 +7002,7 @@
               </a:defRPr>
             </a:pPr>
             <a:r>
-              <a:t>– High-Capacity (HC): blocco 8×8, Δ=24.0, R=1, segreto 64², k=10</a:t>
+              <a:t>– σ₁' = ⌊σ₁/Δ⌋·Δ + 0.25Δ (bit 0)  oppure  + 0.75Δ (bit 1)</a:t>
             </a:r>
           </a:p>
           <a:p>
@@ -5941,7 +7017,7 @@
               </a:defRPr>
             </a:pPr>
             <a:r>
-              <a:t>– Robust (RB): blocco 16×16, Δ=128.0, R=3, segreto 16², k=3</a:t>
+              <a:t>– 0.25 e 0.75 = centri delle due semicelle ⇒ margine simmetrico e massimo Δ/4</a:t>
             </a:r>
           </a:p>
           <a:p>
@@ -5956,7 +7032,7 @@
               </a:defRPr>
             </a:pPr>
             <a:r>
-              <a:t>• Metriche: PSNR, SSIM, MSE; NC e BER del segreto; mAP@0.5 / preservation rate.</a:t>
+              <a:t>• Ricostruzione A' = UΣ'Vᵀ: cambia solo σ₁, i vettori singolari restano invariati.</a:t>
             </a:r>
           </a:p>
           <a:p>
@@ -5971,7 +7047,7 @@
               </a:defRPr>
             </a:pPr>
             <a:r>
-              <a:t>• Attacchi: JPEG q90/q75/q50, rumore gaussiano, blur, mediano, sale&amp;pepe, rescale.</a:t>
+              <a:t>• Codice a ripetizione (×R): ogni bit logico scritto in R siti consecutivi.</a:t>
             </a:r>
           </a:p>
         </p:txBody>
@@ -6067,271 +7143,105 @@
               </a:defRPr>
             </a:pPr>
             <a:r>
-              <a:t>Risultati — impercettibilità (HC)</a:t>
-            </a:r>
-          </a:p>
-        </p:txBody>
-      </p:sp>
-      <p:sp>
-        <p:nvSpPr>
-          <p:cNvPr id="4" name="Rectangle 3"/>
-          <p:cNvSpPr/>
-          <p:nvPr/>
-        </p:nvSpPr>
-        <p:spPr>
-          <a:xfrm>
-            <a:off x="548640" y="2011680"/>
-            <a:ext cx="2567863" cy="2377440"/>
-          </a:xfrm>
-          <a:prstGeom prst="rect">
-            <a:avLst/>
-          </a:prstGeom>
-          <a:solidFill>
-            <a:srgbClr val="F2F4F6"/>
-          </a:solidFill>
-          <a:ln w="25400">
-            <a:solidFill>
-              <a:srgbClr val="2E6DA4"/>
-            </a:solidFill>
-          </a:ln>
-        </p:spPr>
-        <p:style>
-          <a:lnRef idx="1">
-            <a:schemeClr val="accent1"/>
-          </a:lnRef>
-          <a:fillRef idx="3">
-            <a:schemeClr val="accent1"/>
-          </a:fillRef>
-          <a:effectRef idx="2">
-            <a:schemeClr val="accent1"/>
-          </a:effectRef>
-          <a:fontRef idx="minor">
-            <a:schemeClr val="lt1"/>
-          </a:fontRef>
-        </p:style>
-        <p:txBody>
-          <a:bodyPr rtlCol="0" anchor="ctr" wrap="square"/>
-          <a:lstStyle/>
-          <a:p>
-            <a:pPr algn="ctr">
-              <a:defRPr sz="3400" b="1">
-                <a:solidFill>
-                  <a:srgbClr val="2E6DA4"/>
-                </a:solidFill>
-              </a:defRPr>
-            </a:pPr>
-            <a:r>
-              <a:t>47.39 dB</a:t>
-            </a:r>
-          </a:p>
-          <a:p>
-            <a:pPr algn="ctr">
-              <a:defRPr sz="1400">
+              <a:t>Decodifica cieca (estrazione)</a:t>
+            </a:r>
+          </a:p>
+        </p:txBody>
+      </p:sp>
+      <p:sp>
+        <p:nvSpPr>
+          <p:cNvPr id="4" name="TextBox 3"/>
+          <p:cNvSpPr txBox="1"/>
+          <p:nvPr/>
+        </p:nvSpPr>
+        <p:spPr>
+          <a:xfrm>
+            <a:off x="640080" y="1371600"/>
+            <a:ext cx="10972800" cy="4754880"/>
+          </a:xfrm>
+          <a:prstGeom prst="rect">
+            <a:avLst/>
+          </a:prstGeom>
+          <a:noFill/>
+        </p:spPr>
+        <p:txBody>
+          <a:bodyPr wrap="square">
+            <a:spAutoFit/>
+          </a:bodyPr>
+          <a:lstStyle/>
+          <a:p>
+            <a:pPr>
+              <a:spcAft>
+                <a:spcPts val="800"/>
+              </a:spcAft>
+              <a:defRPr sz="2000">
+                <a:solidFill>
+                  <a:srgbClr val="1F3555"/>
+                </a:solidFill>
+              </a:defRPr>
+            </a:pPr>
+            <a:r>
+              <a:t>• Non servono né il cover né i σ originali (≠ Liu–Tan, che conserva U,V): solo chiave, parametri (B, Δ, R) e mappa di priorità.</a:t>
+            </a:r>
+          </a:p>
+          <a:p>
+            <a:pPr>
+              <a:spcAft>
+                <a:spcPts val="800"/>
+              </a:spcAft>
+              <a:defRPr sz="2000">
+                <a:solidFill>
+                  <a:srgbClr val="1F3555"/>
+                </a:solidFill>
+              </a:defRPr>
+            </a:pPr>
+            <a:r>
+              <a:t>• Stesso ordinamento dei blocchi ⇒ per ogni blocco: SVD e decisione dalla parte frazionaria di σ₁/Δ:</a:t>
+            </a:r>
+          </a:p>
+          <a:p>
+            <a:pPr lvl="1">
+              <a:spcAft>
+                <a:spcPts val="800"/>
+              </a:spcAft>
+              <a:defRPr sz="1700">
                 <a:solidFill>
                   <a:srgbClr val="555F6B"/>
                 </a:solidFill>
               </a:defRPr>
             </a:pPr>
             <a:r>
-              <a:t>PSNR cover→stego</a:t>
-            </a:r>
-          </a:p>
-        </p:txBody>
-      </p:sp>
-      <p:sp>
-        <p:nvSpPr>
-          <p:cNvPr id="5" name="Rectangle 4"/>
-          <p:cNvSpPr/>
-          <p:nvPr/>
-        </p:nvSpPr>
-        <p:spPr>
-          <a:xfrm>
-            <a:off x="3390823" y="2011680"/>
-            <a:ext cx="2567863" cy="2377440"/>
-          </a:xfrm>
-          <a:prstGeom prst="rect">
-            <a:avLst/>
-          </a:prstGeom>
-          <a:solidFill>
-            <a:srgbClr val="F2F4F6"/>
-          </a:solidFill>
-          <a:ln w="25400">
-            <a:solidFill>
-              <a:srgbClr val="2E6DA4"/>
-            </a:solidFill>
-          </a:ln>
-        </p:spPr>
-        <p:style>
-          <a:lnRef idx="1">
-            <a:schemeClr val="accent1"/>
-          </a:lnRef>
-          <a:fillRef idx="3">
-            <a:schemeClr val="accent1"/>
-          </a:fillRef>
-          <a:effectRef idx="2">
-            <a:schemeClr val="accent1"/>
-          </a:effectRef>
-          <a:fontRef idx="minor">
-            <a:schemeClr val="lt1"/>
-          </a:fontRef>
-        </p:style>
-        <p:txBody>
-          <a:bodyPr rtlCol="0" anchor="ctr" wrap="square"/>
-          <a:lstStyle/>
-          <a:p>
-            <a:pPr algn="ctr">
-              <a:defRPr sz="3400" b="1">
-                <a:solidFill>
-                  <a:srgbClr val="2E6DA4"/>
-                </a:solidFill>
-              </a:defRPr>
-            </a:pPr>
-            <a:r>
-              <a:t>0.9950</a:t>
-            </a:r>
-          </a:p>
-          <a:p>
-            <a:pPr algn="ctr">
-              <a:defRPr sz="1400">
-                <a:solidFill>
-                  <a:srgbClr val="555F6B"/>
-                </a:solidFill>
-              </a:defRPr>
-            </a:pPr>
-            <a:r>
-              <a:t>SSIM</a:t>
-            </a:r>
-          </a:p>
-        </p:txBody>
-      </p:sp>
-      <p:sp>
-        <p:nvSpPr>
-          <p:cNvPr id="6" name="Rectangle 5"/>
-          <p:cNvSpPr/>
-          <p:nvPr/>
-        </p:nvSpPr>
-        <p:spPr>
-          <a:xfrm>
-            <a:off x="6233007" y="2011680"/>
-            <a:ext cx="2567863" cy="2377440"/>
-          </a:xfrm>
-          <a:prstGeom prst="rect">
-            <a:avLst/>
-          </a:prstGeom>
-          <a:solidFill>
-            <a:srgbClr val="F2F4F6"/>
-          </a:solidFill>
-          <a:ln w="25400">
-            <a:solidFill>
-              <a:srgbClr val="2E6DA4"/>
-            </a:solidFill>
-          </a:ln>
-        </p:spPr>
-        <p:style>
-          <a:lnRef idx="1">
-            <a:schemeClr val="accent1"/>
-          </a:lnRef>
-          <a:fillRef idx="3">
-            <a:schemeClr val="accent1"/>
-          </a:fillRef>
-          <a:effectRef idx="2">
-            <a:schemeClr val="accent1"/>
-          </a:effectRef>
-          <a:fontRef idx="minor">
-            <a:schemeClr val="lt1"/>
-          </a:fontRef>
-        </p:style>
-        <p:txBody>
-          <a:bodyPr rtlCol="0" anchor="ctr" wrap="square"/>
-          <a:lstStyle/>
-          <a:p>
-            <a:pPr algn="ctr">
-              <a:defRPr sz="3400" b="1">
-                <a:solidFill>
-                  <a:srgbClr val="2E6DA4"/>
-                </a:solidFill>
-              </a:defRPr>
-            </a:pPr>
-            <a:r>
-              <a:t>0.0469</a:t>
-            </a:r>
-          </a:p>
-          <a:p>
-            <a:pPr algn="ctr">
-              <a:defRPr sz="1400">
-                <a:solidFill>
-                  <a:srgbClr val="555F6B"/>
-                </a:solidFill>
-              </a:defRPr>
-            </a:pPr>
-            <a:r>
-              <a:t>capacità (bpp)</a:t>
-            </a:r>
-          </a:p>
-        </p:txBody>
-      </p:sp>
-      <p:sp>
-        <p:nvSpPr>
-          <p:cNvPr id="7" name="Rectangle 6"/>
-          <p:cNvSpPr/>
-          <p:nvPr/>
-        </p:nvSpPr>
-        <p:spPr>
-          <a:xfrm>
-            <a:off x="9075191" y="2011680"/>
-            <a:ext cx="2567863" cy="2377440"/>
-          </a:xfrm>
-          <a:prstGeom prst="rect">
-            <a:avLst/>
-          </a:prstGeom>
-          <a:solidFill>
-            <a:srgbClr val="F2F4F6"/>
-          </a:solidFill>
-          <a:ln w="25400">
-            <a:solidFill>
-              <a:srgbClr val="2E6DA4"/>
-            </a:solidFill>
-          </a:ln>
-        </p:spPr>
-        <p:style>
-          <a:lnRef idx="1">
-            <a:schemeClr val="accent1"/>
-          </a:lnRef>
-          <a:fillRef idx="3">
-            <a:schemeClr val="accent1"/>
-          </a:fillRef>
-          <a:effectRef idx="2">
-            <a:schemeClr val="accent1"/>
-          </a:effectRef>
-          <a:fontRef idx="minor">
-            <a:schemeClr val="lt1"/>
-          </a:fontRef>
-        </p:style>
-        <p:txBody>
-          <a:bodyPr rtlCol="0" anchor="ctr" wrap="square"/>
-          <a:lstStyle/>
-          <a:p>
-            <a:pPr algn="ctr">
-              <a:defRPr sz="3400" b="1">
-                <a:solidFill>
-                  <a:srgbClr val="2E6DA4"/>
-                </a:solidFill>
-              </a:defRPr>
-            </a:pPr>
-            <a:r>
-              <a:t>0.923</a:t>
-            </a:r>
-          </a:p>
-          <a:p>
-            <a:pPr algn="ctr">
-              <a:defRPr sz="1400">
-                <a:solidFill>
-                  <a:srgbClr val="555F6B"/>
-                </a:solidFill>
-              </a:defRPr>
-            </a:pPr>
-            <a:r>
-              <a:t>NC segreto (pulito)</a:t>
+              <a:t>– bit = 0 se (σ₁/Δ mod 1) &lt; 0.5, altrimenti 1 — cella di decisione Δ/2, valore embedded al centro ⇒ corretto finché |spostamento di σ₁| &lt; Δ/4</a:t>
+            </a:r>
+          </a:p>
+          <a:p>
+            <a:pPr>
+              <a:spcAft>
+                <a:spcPts val="800"/>
+              </a:spcAft>
+              <a:defRPr sz="2000">
+                <a:solidFill>
+                  <a:srgbClr val="1F3555"/>
+                </a:solidFill>
+              </a:defRPr>
+            </a:pPr>
+            <a:r>
+              <a:t>• Prima i 72 bit dell'header → (h, w, k) → lunghezza esatta del payload; poi voto di maggioranza sugli R siti di ogni bit.</a:t>
+            </a:r>
+          </a:p>
+          <a:p>
+            <a:pPr>
+              <a:spcAft>
+                <a:spcPts val="800"/>
+              </a:spcAft>
+              <a:defRPr sz="2000">
+                <a:solidFill>
+                  <a:srgbClr val="1F3555"/>
+                </a:solidFill>
+              </a:defRPr>
+            </a:pPr>
+            <a:r>
+              <a:t>• Ricostruzione Ŝ = Ũ_k·diag(σ̃)·Ṽ_kᵀ, clip in [0,255]; i σ corrotti (NaN/inf) vengono azzerati ⇒ degrado graduale, mai esplosione.</a:t>
             </a:r>
           </a:p>
         </p:txBody>

</xml_diff>